<commit_message>
docs+deck: final live URL levelfield.vercel.app everywhere
Site live on the git-connected project (all pages 200, on-chain attestation
block served). Deck regenerated with the final URL on slides 1 and 10.

Co-Authored-By: Claude Fable 5 <noreply@anthropic.com>
</commit_message>
<xml_diff>
--- a/demo-deck/levelfield-deck.pptx
+++ b/demo-deck/levelfield-deck.pptx
@@ -1991,7 +1991,7 @@
                 <a:ea typeface="Courier New" pitchFamily="34" charset="-122"/>
                 <a:cs typeface="Courier New" pitchFamily="34" charset="-120"/>
               </a:rPr>
-              <a:t>temporary-express-dune-jjgodnq.vercel.app</a:t>
+              <a:t>levelfield.vercel.app</a:t>
             </a:r>
             <a:endParaRPr lang="en-US" sz="850" dirty="0"/>
           </a:p>
@@ -2554,7 +2554,7 @@
                 <a:ea typeface="Courier New" pitchFamily="34" charset="-122"/>
                 <a:cs typeface="Courier New" pitchFamily="34" charset="-120"/>
               </a:rPr>
-              <a:t>temporary-express-dune-jjgodnq.vercel.app</a:t>
+              <a:t>levelfield.vercel.app</a:t>
             </a:r>
             <a:endParaRPr lang="en-US" sz="900" dirty="0"/>
           </a:p>

</xml_diff>